<commit_message>
data-eng: 3-3·3-4·3-5·4-1 덱 20개(실습점검 4 신설) 재굽기 · 묶음 갱신 (2026-10-10)
Co-Authored-By: Claude Opus 5.5 <noreply@anthropic.com>
</commit_message>
<xml_diff>
--- a/data-eng/decks/w3d3s1.pptx
+++ b/data-eng/decks/w3d3s1.pptx
@@ -3100,7 +3100,7 @@
       <p:grpSpPr/>
       <p:sp>
         <p:nvSpPr>
-          <p:cNvPr id="2" name="Oval 1"/>
+          <p:cNvPr id="2" name="deckgen:decor"/>
           <p:cNvSpPr/>
           <p:nvPr/>
         </p:nvSpPr>
@@ -3130,7 +3130,7 @@
       </p:sp>
       <p:sp>
         <p:nvSpPr>
-          <p:cNvPr id="3" name="Oval 2"/>
+          <p:cNvPr id="3" name="deckgen:decor"/>
           <p:cNvSpPr/>
           <p:nvPr/>
         </p:nvSpPr>
@@ -3160,7 +3160,7 @@
       </p:sp>
       <p:sp>
         <p:nvSpPr>
-          <p:cNvPr id="4" name="Oval 3"/>
+          <p:cNvPr id="4" name="deckgen:decor"/>
           <p:cNvSpPr/>
           <p:nvPr/>
         </p:nvSpPr>
@@ -3190,7 +3190,7 @@
       </p:sp>
       <p:sp>
         <p:nvSpPr>
-          <p:cNvPr id="5" name="Rectangle 4"/>
+          <p:cNvPr id="5" name="deckgen:decor"/>
           <p:cNvSpPr/>
           <p:nvPr/>
         </p:nvSpPr>
@@ -3220,7 +3220,7 @@
       </p:sp>
       <p:sp>
         <p:nvSpPr>
-          <p:cNvPr id="6" name="Oval 5"/>
+          <p:cNvPr id="6" name="deckgen:decor"/>
           <p:cNvSpPr/>
           <p:nvPr/>
         </p:nvSpPr>
@@ -3250,7 +3250,7 @@
       </p:sp>
       <p:sp>
         <p:nvSpPr>
-          <p:cNvPr id="7" name="Oval 6"/>
+          <p:cNvPr id="7" name="deckgen:decor"/>
           <p:cNvSpPr/>
           <p:nvPr/>
         </p:nvSpPr>
@@ -3280,7 +3280,7 @@
       </p:sp>
       <p:sp>
         <p:nvSpPr>
-          <p:cNvPr id="8" name="Oval 7"/>
+          <p:cNvPr id="8" name="deckgen:decor"/>
           <p:cNvSpPr/>
           <p:nvPr/>
         </p:nvSpPr>
@@ -3310,7 +3310,7 @@
       </p:sp>
       <p:sp>
         <p:nvSpPr>
-          <p:cNvPr id="9" name="Oval 8"/>
+          <p:cNvPr id="9" name="deckgen:decor"/>
           <p:cNvSpPr/>
           <p:nvPr/>
         </p:nvSpPr>
@@ -3340,7 +3340,7 @@
       </p:sp>
       <p:sp>
         <p:nvSpPr>
-          <p:cNvPr id="10" name="Rectangle 9"/>
+          <p:cNvPr id="10" name="deckgen:decor"/>
           <p:cNvSpPr/>
           <p:nvPr/>
         </p:nvSpPr>
@@ -3600,7 +3600,7 @@
       <p:grpSpPr/>
       <p:sp>
         <p:nvSpPr>
-          <p:cNvPr id="2" name="Oval 1"/>
+          <p:cNvPr id="2" name="deckgen:decor"/>
           <p:cNvSpPr/>
           <p:nvPr/>
         </p:nvSpPr>
@@ -3630,7 +3630,7 @@
       </p:sp>
       <p:sp>
         <p:nvSpPr>
-          <p:cNvPr id="3" name="Oval 2"/>
+          <p:cNvPr id="3" name="deckgen:decor"/>
           <p:cNvSpPr/>
           <p:nvPr/>
         </p:nvSpPr>
@@ -3660,7 +3660,7 @@
       </p:sp>
       <p:sp>
         <p:nvSpPr>
-          <p:cNvPr id="4" name="Oval 3"/>
+          <p:cNvPr id="4" name="deckgen:decor"/>
           <p:cNvSpPr/>
           <p:nvPr/>
         </p:nvSpPr>
@@ -4662,7 +4662,7 @@
       <p:grpSpPr/>
       <p:sp>
         <p:nvSpPr>
-          <p:cNvPr id="2" name="Oval 1"/>
+          <p:cNvPr id="2" name="deckgen:decor"/>
           <p:cNvSpPr/>
           <p:nvPr/>
         </p:nvSpPr>
@@ -4692,7 +4692,7 @@
       </p:sp>
       <p:sp>
         <p:nvSpPr>
-          <p:cNvPr id="3" name="Oval 2"/>
+          <p:cNvPr id="3" name="deckgen:decor"/>
           <p:cNvSpPr/>
           <p:nvPr/>
         </p:nvSpPr>
@@ -4868,7 +4868,7 @@
                 <a:ea typeface="Pretendard"/>
                 <a:cs typeface="Pretendard"/>
               </a:rPr>
-              <a:t>100만 행 events.csv 를 만들고, 적재 절차 없이 SQL 로 바로 질의해 봅니다</a:t>
+              <a:t>100만 행 events.csv 를 만들고, query.py 에 이어 붙이며 적재 절차 없이 SQL 로 바로 질의합니다</a:t>
             </a:r>
           </a:p>
         </p:txBody>
@@ -4984,7 +4984,7 @@
                 <a:ea typeface="Pretendard"/>
                 <a:cs typeface="Pretendard"/>
               </a:rPr>
-              <a:t>pip install duckdb 와 버전 확인</a:t>
+              <a:t>duckdb 판 확인 — 3-2 정리 때 설치</a:t>
             </a:r>
           </a:p>
         </p:txBody>
@@ -5469,7 +5469,7 @@
       <p:grpSpPr/>
       <p:sp>
         <p:nvSpPr>
-          <p:cNvPr id="2" name="Oval 1"/>
+          <p:cNvPr id="2" name="deckgen:decor"/>
           <p:cNvSpPr/>
           <p:nvPr/>
         </p:nvSpPr>
@@ -5499,7 +5499,7 @@
       </p:sp>
       <p:sp>
         <p:nvSpPr>
-          <p:cNvPr id="3" name="Oval 2"/>
+          <p:cNvPr id="3" name="deckgen:decor"/>
           <p:cNvSpPr/>
           <p:nvPr/>
         </p:nvSpPr>
@@ -5529,7 +5529,7 @@
       </p:sp>
       <p:sp>
         <p:nvSpPr>
-          <p:cNvPr id="4" name="Oval 3"/>
+          <p:cNvPr id="4" name="deckgen:decor"/>
           <p:cNvSpPr/>
           <p:nvPr/>
         </p:nvSpPr>
@@ -6460,7 +6460,7 @@
       <p:grpSpPr/>
       <p:sp>
         <p:nvSpPr>
-          <p:cNvPr id="2" name="Oval 1"/>
+          <p:cNvPr id="2" name="deckgen:decor"/>
           <p:cNvSpPr/>
           <p:nvPr/>
         </p:nvSpPr>
@@ -6490,7 +6490,7 @@
       </p:sp>
       <p:sp>
         <p:nvSpPr>
-          <p:cNvPr id="3" name="Oval 2"/>
+          <p:cNvPr id="3" name="deckgen:decor"/>
           <p:cNvSpPr/>
           <p:nvPr/>
         </p:nvSpPr>
@@ -6520,7 +6520,7 @@
       </p:sp>
       <p:sp>
         <p:nvSpPr>
-          <p:cNvPr id="4" name="Oval 3"/>
+          <p:cNvPr id="4" name="deckgen:decor"/>
           <p:cNvSpPr/>
           <p:nvPr/>
         </p:nvSpPr>
@@ -8091,7 +8091,7 @@
       <p:grpSpPr/>
       <p:sp>
         <p:nvSpPr>
-          <p:cNvPr id="2" name="Oval 1"/>
+          <p:cNvPr id="2" name="deckgen:decor"/>
           <p:cNvSpPr/>
           <p:nvPr/>
         </p:nvSpPr>
@@ -8121,7 +8121,7 @@
       </p:sp>
       <p:sp>
         <p:nvSpPr>
-          <p:cNvPr id="3" name="Oval 2"/>
+          <p:cNvPr id="3" name="deckgen:decor"/>
           <p:cNvSpPr/>
           <p:nvPr/>
         </p:nvSpPr>
@@ -8151,7 +8151,7 @@
       </p:sp>
       <p:sp>
         <p:nvSpPr>
-          <p:cNvPr id="4" name="Oval 3"/>
+          <p:cNvPr id="4" name="deckgen:decor"/>
           <p:cNvSpPr/>
           <p:nvPr/>
         </p:nvSpPr>
@@ -10027,7 +10027,7 @@
       <p:grpSpPr/>
       <p:sp>
         <p:nvSpPr>
-          <p:cNvPr id="2" name="Oval 1"/>
+          <p:cNvPr id="2" name="deckgen:decor"/>
           <p:cNvSpPr/>
           <p:nvPr/>
         </p:nvSpPr>
@@ -10057,7 +10057,7 @@
       </p:sp>
       <p:sp>
         <p:nvSpPr>
-          <p:cNvPr id="3" name="Oval 2"/>
+          <p:cNvPr id="3" name="deckgen:decor"/>
           <p:cNvSpPr/>
           <p:nvPr/>
         </p:nvSpPr>
@@ -10087,7 +10087,7 @@
       </p:sp>
       <p:sp>
         <p:nvSpPr>
-          <p:cNvPr id="4" name="Oval 3"/>
+          <p:cNvPr id="4" name="deckgen:decor"/>
           <p:cNvSpPr/>
           <p:nvPr/>
         </p:nvSpPr>
@@ -11088,7 +11088,7 @@
       <p:grpSpPr/>
       <p:sp>
         <p:nvSpPr>
-          <p:cNvPr id="2" name="Oval 1"/>
+          <p:cNvPr id="2" name="deckgen:decor"/>
           <p:cNvSpPr/>
           <p:nvPr/>
         </p:nvSpPr>
@@ -11118,7 +11118,7 @@
       </p:sp>
       <p:sp>
         <p:nvSpPr>
-          <p:cNvPr id="3" name="Oval 2"/>
+          <p:cNvPr id="3" name="deckgen:decor"/>
           <p:cNvSpPr/>
           <p:nvPr/>
         </p:nvSpPr>
@@ -11148,7 +11148,7 @@
       </p:sp>
       <p:sp>
         <p:nvSpPr>
-          <p:cNvPr id="4" name="Oval 3"/>
+          <p:cNvPr id="4" name="deckgen:decor"/>
           <p:cNvSpPr/>
           <p:nvPr/>
         </p:nvSpPr>
@@ -12115,7 +12115,7 @@
       <p:grpSpPr/>
       <p:sp>
         <p:nvSpPr>
-          <p:cNvPr id="2" name="Oval 1"/>
+          <p:cNvPr id="2" name="deckgen:decor"/>
           <p:cNvSpPr/>
           <p:nvPr/>
         </p:nvSpPr>
@@ -12145,7 +12145,7 @@
       </p:sp>
       <p:sp>
         <p:nvSpPr>
-          <p:cNvPr id="3" name="Oval 2"/>
+          <p:cNvPr id="3" name="deckgen:decor"/>
           <p:cNvSpPr/>
           <p:nvPr/>
         </p:nvSpPr>
@@ -12175,7 +12175,7 @@
       </p:sp>
       <p:sp>
         <p:nvSpPr>
-          <p:cNvPr id="4" name="Oval 3"/>
+          <p:cNvPr id="4" name="deckgen:decor"/>
           <p:cNvSpPr/>
           <p:nvPr/>
         </p:nvSpPr>
@@ -14051,7 +14051,7 @@
       <p:grpSpPr/>
       <p:sp>
         <p:nvSpPr>
-          <p:cNvPr id="2" name="Oval 1"/>
+          <p:cNvPr id="2" name="deckgen:decor"/>
           <p:cNvSpPr/>
           <p:nvPr/>
         </p:nvSpPr>
@@ -14081,7 +14081,7 @@
       </p:sp>
       <p:sp>
         <p:nvSpPr>
-          <p:cNvPr id="3" name="Oval 2"/>
+          <p:cNvPr id="3" name="deckgen:decor"/>
           <p:cNvSpPr/>
           <p:nvPr/>
         </p:nvSpPr>
@@ -14111,7 +14111,7 @@
       </p:sp>
       <p:sp>
         <p:nvSpPr>
-          <p:cNvPr id="4" name="Oval 3"/>
+          <p:cNvPr id="4" name="deckgen:decor"/>
           <p:cNvSpPr/>
           <p:nvPr/>
         </p:nvSpPr>
@@ -15034,7 +15034,7 @@
                 <a:ea typeface="Pretendard"/>
                 <a:cs typeface="Pretendard"/>
               </a:rPr>
-              <a:t>(FORMAT parquet) — 질의 결과를 파일로 바로 저장</a:t>
+              <a:t>(FORMAT parquet) — 압축을 적지 않으면 snappy 로 저장된다</a:t>
             </a:r>
           </a:p>
         </p:txBody>
@@ -15242,7 +15242,7 @@
       <p:grpSpPr/>
       <p:sp>
         <p:nvSpPr>
-          <p:cNvPr id="2" name="Oval 1"/>
+          <p:cNvPr id="2" name="deckgen:decor"/>
           <p:cNvSpPr/>
           <p:nvPr/>
         </p:nvSpPr>
@@ -15272,7 +15272,7 @@
       </p:sp>
       <p:sp>
         <p:nvSpPr>
-          <p:cNvPr id="3" name="Oval 2"/>
+          <p:cNvPr id="3" name="deckgen:decor"/>
           <p:cNvSpPr/>
           <p:nvPr/>
         </p:nvSpPr>
@@ -15302,7 +15302,7 @@
       </p:sp>
       <p:sp>
         <p:nvSpPr>
-          <p:cNvPr id="4" name="Oval 3"/>
+          <p:cNvPr id="4" name="deckgen:decor"/>
           <p:cNvSpPr/>
           <p:nvPr/>
         </p:nvSpPr>
@@ -16962,7 +16962,7 @@
                 <a:ea typeface="Pretendard"/>
                 <a:cs typeface="Pretendard"/>
               </a:rPr>
-              <a:t>4주차 Iceberg 도 같은 선택 — 심화 과제에서 snappy 와 직접 비교해 볼 수 있다</a:t>
+              <a:t>COMPRESSION 을 안 적으면 snappy(1.5.6 실측) — 오늘 COPY 에는 매번 zstd 를 적고, 1.5H 5단계에서 셋을 직접 비교한다</a:t>
             </a:r>
           </a:p>
         </p:txBody>

</xml_diff>